<commit_message>
Compute the last quoted data facts from metrics; make reruns byte-stable; add staleness tests
- FICO floor, raw row count and explained-applicant count rendered from metrics.json
- drop wall-clock timings from metrics; single-threaded DuckDB for small aggregates
- tests fail if README, interview notes, docs or deck spec differ from a fresh render

Co-Authored-By: Claude Opus 5.5 <noreply@anthropic.com>
</commit_message>
<xml_diff>
--- a/deck/Northvale_case_study.pptx
+++ b/deck/Northvale_case_study.pptx
@@ -118,41 +118,41 @@
   <p:extLst>
     <p:ext uri="{521415D9-36F7-43E2-AB2F-B90AF26B5E84}">
       <p14:sectionLst xmlns:p14="http://schemas.microsoft.com/office/powerpoint/2010/main">
-        <p14:section name="Problem" id="{a18e78c8-f5cd-bd0f-7320-9aa95c52919c}">
+        <p14:section name="Problem" id="{b7771827-6a17-dd0f-55b8-1f28b4414671}">
           <p14:sldIdLst>
             <p14:sldId id="257"/>
           </p14:sldIdLst>
         </p14:section>
-        <p14:section name="Default-1" id="{da35ebdb-e9c3-00ad-0ce3-d2d12e70fda6}">
+        <p14:section name="Default-1" id="{b82b852a-d664-804f-db93-d5a821021fd2}">
           <p14:sldIdLst>
             <p14:sldId id="258"/>
             <p14:sldId id="259"/>
           </p14:sldIdLst>
         </p14:section>
-        <p14:section name="Findings" id="{a9c3ab59-1992-a0d0-ada0-720d25849493}">
+        <p14:section name="Findings" id="{4daa77ef-b471-899e-2701-ae1ed0b5ce2d}">
           <p14:sldIdLst>
             <p14:sldId id="260"/>
           </p14:sldIdLst>
         </p14:section>
-        <p14:section name="Default-2" id="{dc0a292b-acad-0ab0-d841-d34d346166f6}">
+        <p14:section name="Default-2" id="{a4ee7407-cc2d-5f3e-658c-4fcf082f3c04}">
           <p14:sldIdLst>
             <p14:sldId id="261"/>
             <p14:sldId id="262"/>
             <p14:sldId id="263"/>
           </p14:sldIdLst>
         </p14:section>
-        <p14:section name="Recommendation" id="{896c3a66-7ad5-0b97-5b33-f90460488d66}">
+        <p14:section name="Recommendation" id="{6dbb8acb-4e34-2e22-9997-27b921172c64}">
           <p14:sldIdLst>
             <p14:sldId id="264"/>
           </p14:sldIdLst>
         </p14:section>
-        <p14:section name="Default-3" id="{9d68e60d-3c77-2be9-f3d0-38e93099e6bd}">
+        <p14:section name="Default-3" id="{9b85fcc8-4ebe-02e3-c25b-0366eeabedba}">
           <p14:sldIdLst>
             <p14:sldId id="265"/>
             <p14:sldId id="266"/>
           </p14:sldIdLst>
         </p14:section>
-        <p14:section name="Appendix" id="{f2c7b406-3f8b-b356-0309-5dd57cc7216f}">
+        <p14:section name="Appendix" id="{a2f21ec3-8e85-c531-9f22-709357d8fabf}">
           <p14:sldIdLst>
             <p14:sldId id="267"/>
           </p14:sldIdLst>

</xml_diff>

<commit_message>
Deck: state the 90% volume floor that separates balanced from conservative
Co-Authored-By: Claude Opus 5.5 <noreply@anthropic.com>
</commit_message>
<xml_diff>
--- a/deck/Northvale_case_study.pptx
+++ b/deck/Northvale_case_study.pptx
@@ -118,41 +118,41 @@
   <p:extLst>
     <p:ext uri="{521415D9-36F7-43E2-AB2F-B90AF26B5E84}">
       <p14:sectionLst xmlns:p14="http://schemas.microsoft.com/office/powerpoint/2010/main">
-        <p14:section name="Problem" id="{b7771827-6a17-dd0f-55b8-1f28b4414671}">
+        <p14:section name="Problem" id="{d5cc3bdb-906f-4ace-e64d-6a6efabc6937}">
           <p14:sldIdLst>
             <p14:sldId id="257"/>
           </p14:sldIdLst>
         </p14:section>
-        <p14:section name="Default-1" id="{b82b852a-d664-804f-db93-d5a821021fd2}">
+        <p14:section name="Default-1" id="{42bf77f7-b334-be7e-6c0a-90d1c7cb57ca}">
           <p14:sldIdLst>
             <p14:sldId id="258"/>
             <p14:sldId id="259"/>
           </p14:sldIdLst>
         </p14:section>
-        <p14:section name="Findings" id="{4daa77ef-b471-899e-2701-ae1ed0b5ce2d}">
+        <p14:section name="Findings" id="{b7967032-79d2-3ff1-3790-c3344ce8184d}">
           <p14:sldIdLst>
             <p14:sldId id="260"/>
           </p14:sldIdLst>
         </p14:section>
-        <p14:section name="Default-2" id="{a4ee7407-cc2d-5f3e-658c-4fcf082f3c04}">
+        <p14:section name="Default-2" id="{8f9d063b-2651-b807-b58c-874a0824142d}">
           <p14:sldIdLst>
             <p14:sldId id="261"/>
             <p14:sldId id="262"/>
             <p14:sldId id="263"/>
           </p14:sldIdLst>
         </p14:section>
-        <p14:section name="Recommendation" id="{6dbb8acb-4e34-2e22-9997-27b921172c64}">
+        <p14:section name="Recommendation" id="{5ccfe0dd-fa45-d501-cb06-e8396dc97a68}">
           <p14:sldIdLst>
             <p14:sldId id="264"/>
           </p14:sldIdLst>
         </p14:section>
-        <p14:section name="Default-3" id="{9b85fcc8-4ebe-02e3-c25b-0366eeabedba}">
+        <p14:section name="Default-3" id="{a636e65b-9312-085c-a52a-24e55beb704f}">
           <p14:sldIdLst>
             <p14:sldId id="265"/>
             <p14:sldId id="266"/>
           </p14:sldIdLst>
         </p14:section>
-        <p14:section name="Appendix" id="{a2f21ec3-8e85-c531-9f22-709357d8fabf}">
+        <p14:section name="Appendix" id="{2f19c201-0359-f07d-8722-26d3c746eff5}">
           <p14:sldIdLst>
             <p14:sldId id="267"/>
           </p14:sldIdLst>
@@ -8117,7 +8117,7 @@
                 <a:ea typeface="Arial" pitchFamily="34" charset="-122"/>
                 <a:cs typeface="Arial" pitchFamily="34" charset="-120"/>
               </a:rPr>
-              <a:t>Cutoffs chosen on Jan-Jun 2015 by expected profit; realized results on 161,997 Jul-Dec 2015 loans. Base cost assumptions.</a:t>
+              <a:t>Conservative maximises expected profit; balanced does so while approving at least 90% of applicants, the committee's volume floor. Chosen on Jan-Jun 2015, judged on 161,997 Jul-Dec 2015 loans.</a:t>
             </a:r>
             <a:endParaRPr lang="en-US" sz="1000" dirty="0"/>
           </a:p>

</xml_diff>